<commit_message>
fix(pptx): move non-conformités block up to prevent overflow
The non-conformités title/content boxes sat near the slide bottom (~6.9"/7.2"
on a 7.5" slide); with auto-fit, longer lists grew off the page. Moved both
into the empty right-column space below the next-week block.
</commit_message>
<xml_diff>
--- a/templates/weekly-report.pptx
+++ b/templates/weekly-report.pptx
@@ -3742,7 +3742,7 @@
         </p:nvSpPr>
         <p:spPr bwMode="auto">
           <a:xfrm>
-            <a:off x="5829889" y="6289595"/>
+            <a:off x="5829889" y="3600000"/>
             <a:ext cx="5848031" cy="261610"/>
           </a:xfrm>
           <a:prstGeom prst="rect">
@@ -4372,7 +4372,7 @@
         </p:nvSpPr>
         <p:spPr bwMode="auto">
           <a:xfrm>
-            <a:off x="5839352" y="6547394"/>
+            <a:off x="5839352" y="3860000"/>
             <a:ext cx="5830756" cy="261610"/>
           </a:xfrm>
           <a:prstGeom prst="rect">

</xml_diff>

<commit_message>
fix(pptx): match hand-made layout — non-conformités at bottom + title spacing
- Revert non-conformités boxes to their original bottom position (the
  earlier overflow fix had moved them up, diverging from the model).
- Add a blank line between Département / Intervenant(s) / Comité Direction
  via a trailing line break (none after the last line so the bottom-anchored
  block fits the banner), matching the manual report.

Co-Authored-By: Claude Opus 4.8 <noreply@anthropic.com>
</commit_message>
<xml_diff>
--- a/templates/weekly-report.pptx
+++ b/templates/weekly-report.pptx
@@ -3742,7 +3742,7 @@
         </p:nvSpPr>
         <p:spPr bwMode="auto">
           <a:xfrm>
-            <a:off x="5829889" y="3600000"/>
+            <a:off x="5829889" y="6289595"/>
             <a:ext cx="5848031" cy="261610"/>
           </a:xfrm>
           <a:prstGeom prst="rect">
@@ -4372,7 +4372,7 @@
         </p:nvSpPr>
         <p:spPr bwMode="auto">
           <a:xfrm>
-            <a:off x="5839352" y="3860000"/>
+            <a:off x="5839352" y="6547394"/>
             <a:ext cx="5830756" cy="261610"/>
           </a:xfrm>
           <a:prstGeom prst="rect">

</xml_diff>